<commit_message>
update train the trainer
</commit_message>
<xml_diff>
--- a/docs/free-rwe-resources/train-the-trainer/training/day-00-environment/kit/Participant-Handout.pptx
+++ b/docs/free-rwe-resources/train-the-trainer/training/day-00-environment/kit/Participant-Handout.pptx
@@ -11,7 +11,7 @@
     <p:sldId id="259" r:id="rId10"/>
     <p:sldId id="260" r:id="rId11"/>
   </p:sldIdLst>
-  <p:sldSz cx="12188952" cy="6858000" type="screen4x3"/>
+  <p:sldSz cx="12192000" cy="6858000" type="screen4x3"/>
   <p:notesSz cx="6858000" cy="9144000"/>
   <p:defaultTextStyle>
     <a:defPPr>
@@ -140,8 +140,8 @@
         </p:nvSpPr>
         <p:spPr>
           <a:xfrm>
-            <a:off x="685800" y="2130425"/>
-            <a:ext cx="7772400" cy="1470025"/>
+            <a:off x="914400" y="2130425"/>
+            <a:ext cx="10363200" cy="1470025"/>
           </a:xfrm>
         </p:spPr>
         <p:txBody>
@@ -168,14 +168,14 @@
         </p:nvSpPr>
         <p:spPr>
           <a:xfrm>
-            <a:off x="1371600" y="3886200"/>
-            <a:ext cx="6400800" cy="1752600"/>
+            <a:off x="1828800" y="3886200"/>
+            <a:ext cx="8534400" cy="1752600"/>
           </a:xfrm>
         </p:spPr>
         <p:txBody>
           <a:bodyPr/>
           <a:lstStyle>
-            <a:lvl1pPr marL="0" indent="0" algn="ctr">
+            <a:lvl1pPr marL="0" indent="0" algn="l">
               <a:buNone/>
               <a:defRPr>
                 <a:solidFill>
@@ -552,8 +552,8 @@
         </p:nvSpPr>
         <p:spPr>
           <a:xfrm>
-            <a:off x="6629400" y="274638"/>
-            <a:ext cx="2057400" cy="5851525"/>
+            <a:off x="8839200" y="274638"/>
+            <a:ext cx="2743200" cy="5851525"/>
           </a:xfrm>
         </p:spPr>
         <p:txBody>
@@ -580,8 +580,8 @@
         </p:nvSpPr>
         <p:spPr>
           <a:xfrm>
-            <a:off x="457200" y="274638"/>
-            <a:ext cx="6019800" cy="5851525"/>
+            <a:off x="609600" y="274638"/>
+            <a:ext cx="8026400" cy="5851525"/>
           </a:xfrm>
         </p:spPr>
         <p:txBody>
@@ -902,46 +902,46 @@
         </p:nvSpPr>
         <p:spPr>
           <a:xfrm>
-            <a:off x="722313" y="4406900"/>
-            <a:ext cx="7772400" cy="1362075"/>
+            <a:off x="963084" y="1920240"/>
+            <a:ext cx="10363200" cy="1280160"/>
           </a:xfrm>
         </p:spPr>
         <p:txBody>
+          <a:bodyPr anchor="b"/>
+          <a:lstStyle>
+            <a:lvl1pPr algn="l">
+              <a:defRPr sz="4000" b="1"/>
+            </a:lvl1pPr>
+          </a:lstStyle>
+          <a:p>
+            <a:r>
+              <a:rPr lang="en-US" smtClean="0"/>
+              <a:t>Click to edit Master title style</a:t>
+            </a:r>
+            <a:endParaRPr lang="en-US"/>
+          </a:p>
+        </p:txBody>
+      </p:sp>
+      <p:sp>
+        <p:nvSpPr>
+          <p:cNvPr id="3" name="Text Placeholder 2"/>
+          <p:cNvSpPr>
+            <a:spLocks noGrp="1"/>
+          </p:cNvSpPr>
+          <p:nvPr>
+            <p:ph type="body" idx="1"/>
+          </p:nvPr>
+        </p:nvSpPr>
+        <p:spPr>
+          <a:xfrm>
+            <a:off x="963084" y="3291840"/>
+            <a:ext cx="10363200" cy="1828800"/>
+          </a:xfrm>
+        </p:spPr>
+        <p:txBody>
           <a:bodyPr anchor="t"/>
           <a:lstStyle>
-            <a:lvl1pPr algn="l">
-              <a:defRPr sz="4000" b="1" cap="all"/>
-            </a:lvl1pPr>
-          </a:lstStyle>
-          <a:p>
-            <a:r>
-              <a:rPr lang="en-US" smtClean="0"/>
-              <a:t>Click to edit Master title style</a:t>
-            </a:r>
-            <a:endParaRPr lang="en-US"/>
-          </a:p>
-        </p:txBody>
-      </p:sp>
-      <p:sp>
-        <p:nvSpPr>
-          <p:cNvPr id="3" name="Text Placeholder 2"/>
-          <p:cNvSpPr>
-            <a:spLocks noGrp="1"/>
-          </p:cNvSpPr>
-          <p:nvPr>
-            <p:ph type="body" idx="1"/>
-          </p:nvPr>
-        </p:nvSpPr>
-        <p:spPr>
-          <a:xfrm>
-            <a:off x="722313" y="2906713"/>
-            <a:ext cx="7772400" cy="1500187"/>
-          </a:xfrm>
-        </p:spPr>
-        <p:txBody>
-          <a:bodyPr anchor="b"/>
-          <a:lstStyle>
-            <a:lvl1pPr marL="0" indent="0">
+            <a:lvl1pPr marL="0" indent="0" algn="l">
               <a:buNone/>
               <a:defRPr sz="2000">
                 <a:solidFill>
@@ -1033,7 +1033,7 @@
             </a:lvl9pPr>
           </a:lstStyle>
           <a:p>
-            <a:pPr lvl="0"/>
+            <a:pPr lvl="0" algn="l"/>
             <a:r>
               <a:rPr lang="en-US" smtClean="0"/>
               <a:t>Click to edit Master text styles</a:t>
@@ -1171,8 +1171,8 @@
         </p:nvSpPr>
         <p:spPr>
           <a:xfrm>
-            <a:off x="457200" y="1600200"/>
-            <a:ext cx="4038600" cy="4525963"/>
+            <a:off x="609600" y="1600200"/>
+            <a:ext cx="5384800" cy="4525963"/>
           </a:xfrm>
         </p:spPr>
         <p:txBody>
@@ -1256,8 +1256,8 @@
         </p:nvSpPr>
         <p:spPr>
           <a:xfrm>
-            <a:off x="4648200" y="1600200"/>
-            <a:ext cx="4038600" cy="4525963"/>
+            <a:off x="6197600" y="1600200"/>
+            <a:ext cx="5384800" cy="4525963"/>
           </a:xfrm>
         </p:spPr>
         <p:txBody>
@@ -1463,8 +1463,8 @@
         </p:nvSpPr>
         <p:spPr>
           <a:xfrm>
-            <a:off x="457200" y="1535113"/>
-            <a:ext cx="4040188" cy="639762"/>
+            <a:off x="609600" y="1535113"/>
+            <a:ext cx="5386917" cy="639762"/>
           </a:xfrm>
         </p:spPr>
         <p:txBody>
@@ -1528,8 +1528,8 @@
         </p:nvSpPr>
         <p:spPr>
           <a:xfrm>
-            <a:off x="457200" y="2174875"/>
-            <a:ext cx="4040188" cy="3951288"/>
+            <a:off x="609600" y="2174875"/>
+            <a:ext cx="5386917" cy="3951288"/>
           </a:xfrm>
         </p:spPr>
         <p:txBody>
@@ -1613,8 +1613,8 @@
         </p:nvSpPr>
         <p:spPr>
           <a:xfrm>
-            <a:off x="4645025" y="1535113"/>
-            <a:ext cx="4041775" cy="639762"/>
+            <a:off x="6193366" y="1535113"/>
+            <a:ext cx="5389033" cy="639762"/>
           </a:xfrm>
         </p:spPr>
         <p:txBody>
@@ -1678,8 +1678,8 @@
         </p:nvSpPr>
         <p:spPr>
           <a:xfrm>
-            <a:off x="4645025" y="2174875"/>
-            <a:ext cx="4041775" cy="3951288"/>
+            <a:off x="6193366" y="2174875"/>
+            <a:ext cx="5389033" cy="3951288"/>
           </a:xfrm>
         </p:spPr>
         <p:txBody>
@@ -2071,8 +2071,8 @@
         </p:nvSpPr>
         <p:spPr>
           <a:xfrm>
-            <a:off x="457200" y="273050"/>
-            <a:ext cx="3008313" cy="1162050"/>
+            <a:off x="609600" y="273050"/>
+            <a:ext cx="4011084" cy="1162050"/>
           </a:xfrm>
         </p:spPr>
         <p:txBody>
@@ -2103,8 +2103,8 @@
         </p:nvSpPr>
         <p:spPr>
           <a:xfrm>
-            <a:off x="3575050" y="273050"/>
-            <a:ext cx="5111750" cy="5853113"/>
+            <a:off x="4766733" y="273050"/>
+            <a:ext cx="6815666" cy="5853113"/>
           </a:xfrm>
         </p:spPr>
         <p:txBody>
@@ -2188,8 +2188,8 @@
         </p:nvSpPr>
         <p:spPr>
           <a:xfrm>
-            <a:off x="457200" y="1435100"/>
-            <a:ext cx="3008313" cy="4691063"/>
+            <a:off x="609600" y="1435100"/>
+            <a:ext cx="4011084" cy="4691063"/>
           </a:xfrm>
         </p:spPr>
         <p:txBody>
@@ -2348,8 +2348,8 @@
         </p:nvSpPr>
         <p:spPr>
           <a:xfrm>
-            <a:off x="1792288" y="4800600"/>
-            <a:ext cx="5486400" cy="566738"/>
+            <a:off x="2389717" y="4800600"/>
+            <a:ext cx="7315200" cy="566738"/>
           </a:xfrm>
         </p:spPr>
         <p:txBody>
@@ -2380,8 +2380,8 @@
         </p:nvSpPr>
         <p:spPr>
           <a:xfrm>
-            <a:off x="1792288" y="612775"/>
-            <a:ext cx="5486400" cy="4114800"/>
+            <a:off x="2389717" y="612775"/>
+            <a:ext cx="7315200" cy="4114800"/>
           </a:xfrm>
         </p:spPr>
         <p:txBody>
@@ -2441,8 +2441,8 @@
         </p:nvSpPr>
         <p:spPr>
           <a:xfrm>
-            <a:off x="1792288" y="5367338"/>
-            <a:ext cx="5486400" cy="804862"/>
+            <a:off x="2389717" y="5367338"/>
+            <a:ext cx="7315200" cy="804862"/>
           </a:xfrm>
         </p:spPr>
         <p:txBody>
@@ -2606,8 +2606,8 @@
         </p:nvSpPr>
         <p:spPr>
           <a:xfrm>
-            <a:off x="457200" y="274638"/>
-            <a:ext cx="8229600" cy="1143000"/>
+            <a:off x="609600" y="274638"/>
+            <a:ext cx="10972800" cy="1143000"/>
           </a:xfrm>
           <a:prstGeom prst="rect">
             <a:avLst/>
@@ -2639,8 +2639,8 @@
         </p:nvSpPr>
         <p:spPr>
           <a:xfrm>
-            <a:off x="457200" y="1600200"/>
-            <a:ext cx="8229600" cy="4525963"/>
+            <a:off x="609600" y="1600200"/>
+            <a:ext cx="10972800" cy="4525963"/>
           </a:xfrm>
           <a:prstGeom prst="rect">
             <a:avLst/>
@@ -2701,8 +2701,8 @@
         </p:nvSpPr>
         <p:spPr>
           <a:xfrm>
-            <a:off x="457200" y="6356350"/>
-            <a:ext cx="2133600" cy="365125"/>
+            <a:off x="609600" y="6356350"/>
+            <a:ext cx="2844800" cy="365125"/>
           </a:xfrm>
           <a:prstGeom prst="rect">
             <a:avLst/>
@@ -2742,8 +2742,8 @@
         </p:nvSpPr>
         <p:spPr>
           <a:xfrm>
-            <a:off x="3124200" y="6356350"/>
-            <a:ext cx="2895600" cy="365125"/>
+            <a:off x="4165600" y="6356350"/>
+            <a:ext cx="3860800" cy="365125"/>
           </a:xfrm>
           <a:prstGeom prst="rect">
             <a:avLst/>
@@ -2779,8 +2779,8 @@
         </p:nvSpPr>
         <p:spPr>
           <a:xfrm>
-            <a:off x="6553200" y="6356350"/>
-            <a:ext cx="2133600" cy="365125"/>
+            <a:off x="8737600" y="6356350"/>
+            <a:ext cx="2844800" cy="365125"/>
           </a:xfrm>
           <a:prstGeom prst="rect">
             <a:avLst/>
@@ -2831,12 +2831,12 @@
   </p:sldLayoutIdLst>
   <p:txStyles>
     <p:titleStyle>
-      <a:lvl1pPr algn="ctr" defTabSz="457200" rtl="0" eaLnBrk="1" latinLnBrk="0" hangingPunct="1">
+      <a:lvl1pPr algn="l" defTabSz="457200" rtl="0" eaLnBrk="1" latinLnBrk="0" hangingPunct="1">
         <a:spcBef>
           <a:spcPct val="0"/>
         </a:spcBef>
         <a:buNone/>
-        <a:defRPr sz="4400" kern="1200">
+        <a:defRPr sz="3200" kern="1200" b="1">
           <a:solidFill>
             <a:schemeClr val="tx1"/>
           </a:solidFill>
@@ -2853,7 +2853,7 @@
         </a:spcBef>
         <a:buFont typeface="Arial"/>
         <a:buChar char="•"/>
-        <a:defRPr sz="3200" kern="1200">
+        <a:defRPr sz="2000" kern="1200">
           <a:solidFill>
             <a:schemeClr val="tx1"/>
           </a:solidFill>
@@ -2868,7 +2868,7 @@
         </a:spcBef>
         <a:buFont typeface="Arial"/>
         <a:buChar char="–"/>
-        <a:defRPr sz="2800" kern="1200">
+        <a:defRPr sz="1800" kern="1200">
           <a:solidFill>
             <a:schemeClr val="tx1"/>
           </a:solidFill>
@@ -2883,7 +2883,7 @@
         </a:spcBef>
         <a:buFont typeface="Arial"/>
         <a:buChar char="•"/>
-        <a:defRPr sz="2400" kern="1200">
+        <a:defRPr sz="1600" kern="1200">
           <a:solidFill>
             <a:schemeClr val="tx1"/>
           </a:solidFill>
@@ -2898,7 +2898,7 @@
         </a:spcBef>
         <a:buFont typeface="Arial"/>
         <a:buChar char="–"/>
-        <a:defRPr sz="2000" kern="1200">
+        <a:defRPr sz="1400" kern="1200">
           <a:solidFill>
             <a:schemeClr val="tx1"/>
           </a:solidFill>
@@ -2913,7 +2913,7 @@
         </a:spcBef>
         <a:buFont typeface="Arial"/>
         <a:buChar char="»"/>
-        <a:defRPr sz="2000" kern="1200">
+        <a:defRPr sz="1400" kern="1200">
           <a:solidFill>
             <a:schemeClr val="tx1"/>
           </a:solidFill>
@@ -3094,312 +3094,65 @@
       <p:grpSpPr/>
       <p:sp>
         <p:nvSpPr>
-          <p:cNvPr id="2" name="Rectangle 1"/>
-          <p:cNvSpPr/>
-          <p:nvPr/>
-        </p:nvSpPr>
-        <p:spPr>
-          <a:xfrm>
-            <a:off x="0" y="0"/>
-            <a:ext cx="12188952" cy="6858000"/>
-          </a:xfrm>
-          <a:prstGeom prst="rect">
-            <a:avLst/>
-          </a:prstGeom>
-          <a:solidFill>
-            <a:srgbClr val="20425A"/>
-          </a:solidFill>
-          <a:ln>
-            <a:noFill/>
-          </a:ln>
-        </p:spPr>
-        <p:style>
-          <a:lnRef idx="1">
-            <a:schemeClr val="accent1"/>
-          </a:lnRef>
-          <a:fillRef idx="3">
-            <a:schemeClr val="accent1"/>
-          </a:fillRef>
-          <a:effectRef idx="2">
-            <a:schemeClr val="accent1"/>
-          </a:effectRef>
-          <a:fontRef idx="minor">
-            <a:schemeClr val="lt1"/>
-          </a:fontRef>
-        </p:style>
-        <p:txBody>
-          <a:bodyPr rtlCol="0" anchor="ctr"/>
-          <a:lstStyle/>
-          <a:p>
-            <a:pPr algn="ctr"/>
-          </a:p>
-        </p:txBody>
-      </p:sp>
-      <p:sp>
-        <p:nvSpPr>
-          <p:cNvPr id="3" name="Rectangle 2"/>
-          <p:cNvSpPr/>
-          <p:nvPr/>
-        </p:nvSpPr>
-        <p:spPr>
-          <a:xfrm>
-            <a:off x="0" y="0"/>
-            <a:ext cx="12188952" cy="64008"/>
-          </a:xfrm>
-          <a:prstGeom prst="rect">
-            <a:avLst/>
-          </a:prstGeom>
-          <a:solidFill>
-            <a:srgbClr val="904199"/>
-          </a:solidFill>
-          <a:ln>
-            <a:noFill/>
-          </a:ln>
-        </p:spPr>
-        <p:style>
-          <a:lnRef idx="1">
-            <a:schemeClr val="accent1"/>
-          </a:lnRef>
-          <a:fillRef idx="3">
-            <a:schemeClr val="accent1"/>
-          </a:fillRef>
-          <a:effectRef idx="2">
-            <a:schemeClr val="accent1"/>
-          </a:effectRef>
-          <a:fontRef idx="minor">
-            <a:schemeClr val="lt1"/>
-          </a:fontRef>
-        </p:style>
-        <p:txBody>
-          <a:bodyPr rtlCol="0" anchor="ctr"/>
-          <a:lstStyle/>
-          <a:p>
-            <a:pPr algn="ctr"/>
-          </a:p>
-        </p:txBody>
-      </p:sp>
-      <p:sp>
-        <p:nvSpPr>
-          <p:cNvPr id="4" name="Rectangle 3"/>
-          <p:cNvSpPr/>
-          <p:nvPr/>
-        </p:nvSpPr>
-        <p:spPr>
-          <a:xfrm>
-            <a:off x="0" y="6793992"/>
-            <a:ext cx="12188952" cy="64008"/>
-          </a:xfrm>
-          <a:prstGeom prst="rect">
-            <a:avLst/>
-          </a:prstGeom>
-          <a:solidFill>
-            <a:srgbClr val="904199"/>
-          </a:solidFill>
-          <a:ln>
-            <a:noFill/>
-          </a:ln>
-        </p:spPr>
-        <p:style>
-          <a:lnRef idx="1">
-            <a:schemeClr val="accent1"/>
-          </a:lnRef>
-          <a:fillRef idx="3">
-            <a:schemeClr val="accent1"/>
-          </a:fillRef>
-          <a:effectRef idx="2">
-            <a:schemeClr val="accent1"/>
-          </a:effectRef>
-          <a:fontRef idx="minor">
-            <a:schemeClr val="lt1"/>
-          </a:fontRef>
-        </p:style>
-        <p:txBody>
-          <a:bodyPr rtlCol="0" anchor="ctr"/>
-          <a:lstStyle/>
-          <a:p>
-            <a:pPr algn="ctr"/>
-          </a:p>
-        </p:txBody>
-      </p:sp>
-      <p:sp>
-        <p:nvSpPr>
-          <p:cNvPr id="5" name="Rectangle 4"/>
-          <p:cNvSpPr/>
-          <p:nvPr/>
-        </p:nvSpPr>
-        <p:spPr>
-          <a:xfrm>
-            <a:off x="475488" y="1188720"/>
-            <a:ext cx="3291840" cy="457200"/>
-          </a:xfrm>
-          <a:prstGeom prst="rect">
-            <a:avLst/>
-          </a:prstGeom>
-          <a:solidFill>
-            <a:srgbClr val="904199"/>
-          </a:solidFill>
-          <a:ln>
-            <a:noFill/>
-          </a:ln>
-        </p:spPr>
-        <p:style>
-          <a:lnRef idx="1">
-            <a:schemeClr val="accent1"/>
-          </a:lnRef>
-          <a:fillRef idx="3">
-            <a:schemeClr val="accent1"/>
-          </a:fillRef>
-          <a:effectRef idx="2">
-            <a:schemeClr val="accent1"/>
-          </a:effectRef>
-          <a:fontRef idx="minor">
-            <a:schemeClr val="lt1"/>
-          </a:fontRef>
-        </p:style>
-        <p:txBody>
-          <a:bodyPr rtlCol="0" anchor="ctr"/>
-          <a:lstStyle/>
-          <a:p>
-            <a:pPr algn="ctr"/>
-          </a:p>
-        </p:txBody>
-      </p:sp>
-      <p:sp>
-        <p:nvSpPr>
-          <p:cNvPr id="6" name="TextBox 5"/>
-          <p:cNvSpPr txBox="1"/>
-          <p:nvPr/>
-        </p:nvSpPr>
-        <p:spPr>
-          <a:xfrm>
-            <a:off x="585216" y="1252728"/>
-            <a:ext cx="3108960" cy="365760"/>
-          </a:xfrm>
-          <a:prstGeom prst="rect">
-            <a:avLst/>
-          </a:prstGeom>
-          <a:noFill/>
-        </p:spPr>
-        <p:txBody>
-          <a:bodyPr wrap="square">
-            <a:spAutoFit/>
-          </a:bodyPr>
-          <a:lstStyle/>
-          <a:p>
-            <a:pPr algn="l"/>
-            <a:r>
-              <a:rPr sz="1400" b="1" i="0">
-                <a:solidFill>
-                  <a:srgbClr val="FFFFFF"/>
-                </a:solidFill>
-                <a:latin typeface="Gotham Narrow"/>
-              </a:rPr>
+          <p:cNvPr id="2" name="Title 1"/>
+          <p:cNvSpPr>
+            <a:spLocks noGrp="1"/>
+          </p:cNvSpPr>
+          <p:nvPr>
+            <p:ph type="ctrTitle"/>
+          </p:nvPr>
+        </p:nvSpPr>
+        <p:spPr/>
+        <p:txBody>
+          <a:bodyPr/>
+          <a:lstStyle/>
+          <a:p>
+            <a:r>
+              <a:t>Environment Setup</a:t>
+            </a:r>
+          </a:p>
+          <a:p>
+            <a:r>
+              <a:t>and Access</a:t>
+            </a:r>
+          </a:p>
+        </p:txBody>
+      </p:sp>
+      <p:sp>
+        <p:nvSpPr>
+          <p:cNvPr id="3" name="Subtitle 2"/>
+          <p:cNvSpPr>
+            <a:spLocks noGrp="1"/>
+          </p:cNvSpPr>
+          <p:nvPr>
+            <p:ph type="subTitle" idx="1"/>
+          </p:nvPr>
+        </p:nvSpPr>
+        <p:spPr/>
+        <p:txBody>
+          <a:bodyPr/>
+          <a:lstStyle/>
+          <a:p>
+            <a:pPr marL="0" indent="0">
+              <a:buNone/>
+            </a:pPr>
+            <a:r>
               <a:t>MODULE 0</a:t>
             </a:r>
           </a:p>
-        </p:txBody>
-      </p:sp>
-      <p:sp>
-        <p:nvSpPr>
-          <p:cNvPr id="7" name="TextBox 6"/>
-          <p:cNvSpPr txBox="1"/>
-          <p:nvPr/>
-        </p:nvSpPr>
-        <p:spPr>
-          <a:xfrm>
-            <a:off x="475488" y="1920240"/>
-            <a:ext cx="11237976" cy="2194560"/>
-          </a:xfrm>
-          <a:prstGeom prst="rect">
-            <a:avLst/>
-          </a:prstGeom>
-          <a:noFill/>
-        </p:spPr>
-        <p:txBody>
-          <a:bodyPr wrap="square">
-            <a:spAutoFit/>
-          </a:bodyPr>
-          <a:lstStyle/>
-          <a:p>
-            <a:pPr algn="l"/>
-            <a:r>
-              <a:rPr sz="4000" b="1" i="0">
-                <a:solidFill>
-                  <a:srgbClr val="FFFFFF"/>
-                </a:solidFill>
-                <a:latin typeface="Gotham Narrow"/>
-              </a:rPr>
-              <a:t>Environment Setup
-and Access</a:t>
-            </a:r>
-          </a:p>
-        </p:txBody>
-      </p:sp>
-      <p:sp>
-        <p:nvSpPr>
-          <p:cNvPr id="8" name="TextBox 7"/>
-          <p:cNvSpPr txBox="1"/>
-          <p:nvPr/>
-        </p:nvSpPr>
-        <p:spPr>
-          <a:xfrm>
-            <a:off x="475488" y="4297680"/>
-            <a:ext cx="11237976" cy="1005840"/>
-          </a:xfrm>
-          <a:prstGeom prst="rect">
-            <a:avLst/>
-          </a:prstGeom>
-          <a:noFill/>
-        </p:spPr>
-        <p:txBody>
-          <a:bodyPr wrap="square">
-            <a:spAutoFit/>
-          </a:bodyPr>
-          <a:lstStyle/>
-          <a:p>
-            <a:pPr algn="l"/>
-            <a:r>
-              <a:rPr sz="2200" b="0" i="0">
-                <a:solidFill>
-                  <a:srgbClr val="D9C4E6"/>
-                </a:solidFill>
-                <a:latin typeface="Arial"/>
-              </a:rPr>
+          <a:p>
+            <a:pPr marL="0" indent="0">
+              <a:buNone/>
+            </a:pPr>
+            <a:r>
               <a:t>Participant Handout · Complete before Day 1</a:t>
             </a:r>
           </a:p>
-        </p:txBody>
-      </p:sp>
-      <p:sp>
-        <p:nvSpPr>
-          <p:cNvPr id="9" name="TextBox 8"/>
-          <p:cNvSpPr txBox="1"/>
-          <p:nvPr/>
-        </p:nvSpPr>
-        <p:spPr>
-          <a:xfrm>
-            <a:off x="475488" y="6355080"/>
-            <a:ext cx="7315200" cy="365760"/>
-          </a:xfrm>
-          <a:prstGeom prst="rect">
-            <a:avLst/>
-          </a:prstGeom>
-          <a:noFill/>
-        </p:spPr>
-        <p:txBody>
-          <a:bodyPr wrap="square">
-            <a:spAutoFit/>
-          </a:bodyPr>
-          <a:lstStyle/>
-          <a:p>
-            <a:pPr algn="l"/>
-            <a:r>
-              <a:rPr sz="1300" b="0" i="0">
-                <a:solidFill>
-                  <a:srgbClr val="AEC4D2"/>
-                </a:solidFill>
-                <a:latin typeface="Arial"/>
-              </a:rPr>
+          <a:p>
+            <a:pPr marL="0" indent="0">
+              <a:buNone/>
+            </a:pPr>
+            <a:r>
               <a:t>ALS TDI · OHDSI/OMOP Train-the-Trainer</a:t>
             </a:r>
           </a:p>
@@ -3425,120 +3178,20 @@
       <p:grpSpPr/>
       <p:sp>
         <p:nvSpPr>
-          <p:cNvPr id="2" name="Rectangle 1"/>
-          <p:cNvSpPr/>
-          <p:nvPr/>
-        </p:nvSpPr>
-        <p:spPr>
-          <a:xfrm>
-            <a:off x="0" y="0"/>
-            <a:ext cx="12188952" cy="960120"/>
-          </a:xfrm>
-          <a:prstGeom prst="rect">
-            <a:avLst/>
-          </a:prstGeom>
-          <a:solidFill>
-            <a:srgbClr val="20425A"/>
-          </a:solidFill>
-          <a:ln>
-            <a:noFill/>
-          </a:ln>
-        </p:spPr>
-        <p:style>
-          <a:lnRef idx="1">
-            <a:schemeClr val="accent1"/>
-          </a:lnRef>
-          <a:fillRef idx="3">
-            <a:schemeClr val="accent1"/>
-          </a:fillRef>
-          <a:effectRef idx="2">
-            <a:schemeClr val="accent1"/>
-          </a:effectRef>
-          <a:fontRef idx="minor">
-            <a:schemeClr val="lt1"/>
-          </a:fontRef>
-        </p:style>
-        <p:txBody>
-          <a:bodyPr rtlCol="0" anchor="ctr"/>
-          <a:lstStyle/>
-          <a:p>
-            <a:pPr algn="ctr"/>
-          </a:p>
-        </p:txBody>
-      </p:sp>
-      <p:sp>
-        <p:nvSpPr>
-          <p:cNvPr id="3" name="Rectangle 2"/>
-          <p:cNvSpPr/>
-          <p:nvPr/>
-        </p:nvSpPr>
-        <p:spPr>
-          <a:xfrm>
-            <a:off x="0" y="905256"/>
-            <a:ext cx="12188952" cy="54864"/>
-          </a:xfrm>
-          <a:prstGeom prst="rect">
-            <a:avLst/>
-          </a:prstGeom>
-          <a:solidFill>
-            <a:srgbClr val="904199"/>
-          </a:solidFill>
-          <a:ln>
-            <a:noFill/>
-          </a:ln>
-        </p:spPr>
-        <p:style>
-          <a:lnRef idx="1">
-            <a:schemeClr val="accent1"/>
-          </a:lnRef>
-          <a:fillRef idx="3">
-            <a:schemeClr val="accent1"/>
-          </a:fillRef>
-          <a:effectRef idx="2">
-            <a:schemeClr val="accent1"/>
-          </a:effectRef>
-          <a:fontRef idx="minor">
-            <a:schemeClr val="lt1"/>
-          </a:fontRef>
-        </p:style>
-        <p:txBody>
-          <a:bodyPr rtlCol="0" anchor="ctr"/>
-          <a:lstStyle/>
-          <a:p>
-            <a:pPr algn="ctr"/>
-          </a:p>
-        </p:txBody>
-      </p:sp>
-      <p:sp>
-        <p:nvSpPr>
-          <p:cNvPr id="4" name="TextBox 3"/>
-          <p:cNvSpPr txBox="1"/>
-          <p:nvPr/>
-        </p:nvSpPr>
-        <p:spPr>
-          <a:xfrm>
-            <a:off x="475488" y="137160"/>
-            <a:ext cx="11713464" cy="777240"/>
-          </a:xfrm>
-          <a:prstGeom prst="rect">
-            <a:avLst/>
-          </a:prstGeom>
-          <a:noFill/>
-        </p:spPr>
-        <p:txBody>
-          <a:bodyPr wrap="square">
-            <a:spAutoFit/>
-          </a:bodyPr>
-          <a:lstStyle/>
-          <a:p>
-            <a:pPr algn="l"/>
-            <a:r>
-              <a:rPr sz="2800" b="1" i="0">
-                <a:solidFill>
-                  <a:srgbClr val="FFFFFF"/>
-                </a:solidFill>
-                <a:latin typeface="Gotham Narrow"/>
-              </a:rPr>
+          <p:cNvPr id="2" name="Title 1"/>
+          <p:cNvSpPr>
+            <a:spLocks noGrp="1"/>
+          </p:cNvSpPr>
+          <p:nvPr>
+            <p:ph type="title"/>
+          </p:nvPr>
+        </p:nvSpPr>
+        <p:spPr/>
+        <p:txBody>
+          <a:bodyPr/>
+          <a:lstStyle/>
+          <a:p>
+            <a:r>
               <a:t>Your Setup Checklist</a:t>
             </a:r>
           </a:p>
@@ -3546,501 +3199,396 @@
       </p:sp>
       <p:graphicFrame>
         <p:nvGraphicFramePr>
-          <p:cNvPr id="5" name="Table 4"/>
+          <p:cNvPr id="3" name="Table 2"/>
           <p:cNvGraphicFramePr>
             <a:graphicFrameLocks noGrp="1"/>
           </p:cNvGraphicFramePr>
           <p:nvPr/>
         </p:nvGraphicFramePr>
         <p:xfrm>
-          <a:off x="475488" y="1143000"/>
-          <a:ext cx="10698480" cy="3968496"/>
+          <a:off x="612648" y="1417320"/>
+          <a:ext cx="10966702" cy="3657600"/>
         </p:xfrm>
         <a:graphic>
           <a:graphicData uri="http://schemas.openxmlformats.org/drawingml/2006/table">
             <a:tbl>
-              <a:tblPr firstRow="1" bandRow="1">
-                <a:tableStyleId>{5C22544A-7EE6-4342-B048-85BDC9FD1C3A}</a:tableStyleId>
+              <a:tblPr firstRow="1">
+                <a:tableStyleId>{5940675A-B579-460E-94D1-54222C63F5DA}</a:tableStyleId>
               </a:tblPr>
               <a:tblGrid>
-                <a:gridCol w="2011680"/>
-                <a:gridCol w="6858000"/>
-                <a:gridCol w="1828800"/>
+                <a:gridCol w="2374234"/>
+                <a:gridCol w="6218234"/>
+                <a:gridCol w="2374234"/>
               </a:tblGrid>
-              <a:tr h="566928">
+              <a:tr h="400050">
                 <a:tc>
                   <a:txBody>
-                    <a:bodyPr lIns="63500" tIns="38100"/>
+                    <a:bodyPr wrap="square"/>
                     <a:lstStyle/>
                     <a:p>
                       <a:r>
-                        <a:rPr sz="1400" b="1">
+                        <a:rPr sz="1800" b="1">
                           <a:solidFill>
-                            <a:srgbClr val="FFFFFF"/>
+                            <a:srgbClr val="000000"/>
                           </a:solidFill>
-                          <a:latin typeface="Gotham Narrow"/>
                         </a:rPr>
                         <a:t>Item</a:t>
                       </a:r>
                     </a:p>
                   </a:txBody>
-                  <a:tcPr>
-                    <a:solidFill>
-                      <a:srgbClr val="20425A"/>
-                    </a:solidFill>
-                  </a:tcPr>
+                  <a:tcPr marL="73152" marR="73152" marT="27432" marB="27432"/>
                 </a:tc>
                 <a:tc>
                   <a:txBody>
-                    <a:bodyPr lIns="63500" tIns="38100"/>
+                    <a:bodyPr wrap="square"/>
                     <a:lstStyle/>
                     <a:p>
                       <a:r>
-                        <a:rPr sz="1400" b="1">
+                        <a:rPr sz="1800" b="1">
                           <a:solidFill>
-                            <a:srgbClr val="FFFFFF"/>
+                            <a:srgbClr val="000000"/>
                           </a:solidFill>
-                          <a:latin typeface="Gotham Narrow"/>
                         </a:rPr>
                         <a:t>What to Do</a:t>
                       </a:r>
                     </a:p>
                   </a:txBody>
-                  <a:tcPr>
-                    <a:solidFill>
-                      <a:srgbClr val="20425A"/>
-                    </a:solidFill>
-                  </a:tcPr>
+                  <a:tcPr marL="73152" marR="73152" marT="27432" marB="27432"/>
                 </a:tc>
                 <a:tc>
                   <a:txBody>
-                    <a:bodyPr lIns="63500" tIns="38100"/>
+                    <a:bodyPr wrap="square"/>
                     <a:lstStyle/>
                     <a:p>
                       <a:r>
-                        <a:rPr sz="1400" b="1">
+                        <a:rPr sz="1800" b="1">
                           <a:solidFill>
-                            <a:srgbClr val="FFFFFF"/>
+                            <a:srgbClr val="000000"/>
                           </a:solidFill>
-                          <a:latin typeface="Gotham Narrow"/>
                         </a:rPr>
                         <a:t>Status</a:t>
                       </a:r>
                     </a:p>
                   </a:txBody>
-                  <a:tcPr>
-                    <a:solidFill>
-                      <a:srgbClr val="20425A"/>
-                    </a:solidFill>
-                  </a:tcPr>
+                  <a:tcPr marL="73152" marR="73152" marT="27432" marB="27432"/>
                 </a:tc>
               </a:tr>
-              <a:tr h="566928">
+              <a:tr h="685800">
                 <a:tc>
                   <a:txBody>
-                    <a:bodyPr lIns="63500" tIns="25400"/>
+                    <a:bodyPr wrap="square"/>
                     <a:lstStyle/>
                     <a:p>
                       <a:r>
-                        <a:rPr sz="1300">
+                        <a:rPr sz="1800">
                           <a:solidFill>
-                            <a:srgbClr val="191919"/>
+                            <a:srgbClr val="000000"/>
                           </a:solidFill>
-                          <a:latin typeface="Arial"/>
                         </a:rPr>
                         <a:t>ATLAS Login</a:t>
                       </a:r>
                     </a:p>
                   </a:txBody>
-                  <a:tcPr>
-                    <a:solidFill>
-                      <a:srgbClr val="F6F6F6"/>
-                    </a:solidFill>
-                  </a:tcPr>
+                  <a:tcPr marL="73152" marR="73152" marT="27432" marB="27432"/>
                 </a:tc>
                 <a:tc>
                   <a:txBody>
-                    <a:bodyPr lIns="63500" tIns="25400"/>
+                    <a:bodyPr wrap="square"/>
                     <a:lstStyle/>
                     <a:p>
                       <a:r>
-                        <a:rPr sz="1300">
+                        <a:rPr sz="1800">
                           <a:solidFill>
-                            <a:srgbClr val="191919"/>
+                            <a:srgbClr val="000000"/>
                           </a:solidFill>
-                          <a:latin typeface="Arial"/>
                         </a:rPr>
                         <a:t>Log in to your site's ATLAS and save a test concept set</a:t>
                       </a:r>
                     </a:p>
                   </a:txBody>
-                  <a:tcPr>
-                    <a:solidFill>
-                      <a:srgbClr val="F6F6F6"/>
-                    </a:solidFill>
-                  </a:tcPr>
+                  <a:tcPr marL="73152" marR="73152" marT="27432" marB="27432"/>
                 </a:tc>
                 <a:tc>
                   <a:txBody>
-                    <a:bodyPr lIns="63500" tIns="25400"/>
+                    <a:bodyPr wrap="square"/>
                     <a:lstStyle/>
                     <a:p>
                       <a:r>
-                        <a:rPr sz="1300">
+                        <a:rPr sz="1800">
                           <a:solidFill>
-                            <a:srgbClr val="191919"/>
+                            <a:srgbClr val="000000"/>
                           </a:solidFill>
-                          <a:latin typeface="Arial"/>
                         </a:rPr>
                         <a:t>☐ Done  ☐ Blocked</a:t>
                       </a:r>
                     </a:p>
                   </a:txBody>
-                  <a:tcPr>
-                    <a:solidFill>
-                      <a:srgbClr val="F6F6F6"/>
-                    </a:solidFill>
-                  </a:tcPr>
+                  <a:tcPr marL="73152" marR="73152" marT="27432" marB="27432"/>
                 </a:tc>
               </a:tr>
-              <a:tr h="566928">
+              <a:tr h="400050">
                 <a:tc>
                   <a:txBody>
-                    <a:bodyPr lIns="63500" tIns="25400"/>
+                    <a:bodyPr wrap="square"/>
                     <a:lstStyle/>
                     <a:p>
                       <a:r>
-                        <a:rPr sz="1300">
+                        <a:rPr sz="1800">
                           <a:solidFill>
-                            <a:srgbClr val="191919"/>
+                            <a:srgbClr val="000000"/>
                           </a:solidFill>
-                          <a:latin typeface="Arial"/>
                         </a:rPr>
                         <a:t>CDM SQL Access</a:t>
                       </a:r>
                     </a:p>
                   </a:txBody>
-                  <a:tcPr>
-                    <a:solidFill>
-                      <a:srgbClr val="FFFFFF"/>
-                    </a:solidFill>
-                  </a:tcPr>
+                  <a:tcPr marL="73152" marR="73152" marT="27432" marB="27432"/>
                 </a:tc>
                 <a:tc>
                   <a:txBody>
-                    <a:bodyPr lIns="63500" tIns="25400"/>
+                    <a:bodyPr wrap="square"/>
                     <a:lstStyle/>
                     <a:p>
                       <a:r>
-                        <a:rPr sz="1300">
+                        <a:rPr sz="1800">
                           <a:solidFill>
-                            <a:srgbClr val="191919"/>
+                            <a:srgbClr val="000000"/>
                           </a:solidFill>
-                          <a:latin typeface="Arial"/>
                         </a:rPr>
                         <a:t>Run SELECT * FROM person LIMIT 5 in your SQL client</a:t>
                       </a:r>
                     </a:p>
                   </a:txBody>
-                  <a:tcPr>
-                    <a:solidFill>
-                      <a:srgbClr val="FFFFFF"/>
-                    </a:solidFill>
-                  </a:tcPr>
+                  <a:tcPr marL="73152" marR="73152" marT="27432" marB="27432"/>
                 </a:tc>
                 <a:tc>
                   <a:txBody>
-                    <a:bodyPr lIns="63500" tIns="25400"/>
+                    <a:bodyPr wrap="square"/>
                     <a:lstStyle/>
                     <a:p>
                       <a:r>
-                        <a:rPr sz="1300">
+                        <a:rPr sz="1800">
                           <a:solidFill>
-                            <a:srgbClr val="191919"/>
+                            <a:srgbClr val="000000"/>
                           </a:solidFill>
-                          <a:latin typeface="Arial"/>
                         </a:rPr>
                         <a:t>☐ Done  ☐ Blocked</a:t>
                       </a:r>
                     </a:p>
                   </a:txBody>
-                  <a:tcPr>
-                    <a:solidFill>
-                      <a:srgbClr val="FFFFFF"/>
-                    </a:solidFill>
-                  </a:tcPr>
+                  <a:tcPr marL="73152" marR="73152" marT="27432" marB="27432"/>
                 </a:tc>
               </a:tr>
-              <a:tr h="566928">
+              <a:tr h="400050">
                 <a:tc>
                   <a:txBody>
-                    <a:bodyPr lIns="63500" tIns="25400"/>
+                    <a:bodyPr wrap="square"/>
                     <a:lstStyle/>
                     <a:p>
                       <a:r>
-                        <a:rPr sz="1300">
+                        <a:rPr sz="1800">
                           <a:solidFill>
-                            <a:srgbClr val="191919"/>
+                            <a:srgbClr val="000000"/>
                           </a:solidFill>
-                          <a:latin typeface="Arial"/>
                         </a:rPr>
                         <a:t>Athena</a:t>
                       </a:r>
                     </a:p>
                   </a:txBody>
-                  <a:tcPr>
-                    <a:solidFill>
-                      <a:srgbClr val="F6F6F6"/>
-                    </a:solidFill>
-                  </a:tcPr>
+                  <a:tcPr marL="73152" marR="73152" marT="27432" marB="27432"/>
                 </a:tc>
                 <a:tc>
                   <a:txBody>
-                    <a:bodyPr lIns="63500" tIns="25400"/>
+                    <a:bodyPr wrap="square"/>
                     <a:lstStyle/>
                     <a:p>
                       <a:r>
-                        <a:rPr sz="1300">
+                        <a:rPr sz="1800">
                           <a:solidFill>
-                            <a:srgbClr val="191919"/>
+                            <a:srgbClr val="000000"/>
                           </a:solidFill>
-                          <a:latin typeface="Arial"/>
                         </a:rPr>
                         <a:t>Open athena.ohdsi.org and search for Metformin</a:t>
                       </a:r>
                     </a:p>
                   </a:txBody>
-                  <a:tcPr>
-                    <a:solidFill>
-                      <a:srgbClr val="F6F6F6"/>
-                    </a:solidFill>
-                  </a:tcPr>
+                  <a:tcPr marL="73152" marR="73152" marT="27432" marB="27432"/>
                 </a:tc>
                 <a:tc>
                   <a:txBody>
-                    <a:bodyPr lIns="63500" tIns="25400"/>
+                    <a:bodyPr wrap="square"/>
                     <a:lstStyle/>
                     <a:p>
                       <a:r>
-                        <a:rPr sz="1300">
+                        <a:rPr sz="1800">
                           <a:solidFill>
-                            <a:srgbClr val="191919"/>
+                            <a:srgbClr val="000000"/>
                           </a:solidFill>
-                          <a:latin typeface="Arial"/>
                         </a:rPr>
                         <a:t>☐ Done  ☐ Blocked</a:t>
                       </a:r>
                     </a:p>
                   </a:txBody>
-                  <a:tcPr>
-                    <a:solidFill>
-                      <a:srgbClr val="F6F6F6"/>
-                    </a:solidFill>
-                  </a:tcPr>
+                  <a:tcPr marL="73152" marR="73152" marT="27432" marB="27432"/>
                 </a:tc>
               </a:tr>
-              <a:tr h="566928">
+              <a:tr h="685800">
                 <a:tc>
                   <a:txBody>
-                    <a:bodyPr lIns="63500" tIns="25400"/>
+                    <a:bodyPr wrap="square"/>
                     <a:lstStyle/>
                     <a:p>
                       <a:r>
-                        <a:rPr sz="1300">
+                        <a:rPr sz="1800">
                           <a:solidFill>
-                            <a:srgbClr val="191919"/>
+                            <a:srgbClr val="000000"/>
                           </a:solidFill>
-                          <a:latin typeface="Arial"/>
                         </a:rPr>
                         <a:t>SQL Client</a:t>
                       </a:r>
                     </a:p>
                   </a:txBody>
-                  <a:tcPr>
-                    <a:solidFill>
-                      <a:srgbClr val="FFFFFF"/>
-                    </a:solidFill>
-                  </a:tcPr>
+                  <a:tcPr marL="73152" marR="73152" marT="27432" marB="27432"/>
                 </a:tc>
                 <a:tc>
                   <a:txBody>
-                    <a:bodyPr lIns="63500" tIns="25400"/>
+                    <a:bodyPr wrap="square"/>
                     <a:lstStyle/>
                     <a:p>
                       <a:r>
-                        <a:rPr sz="1300">
+                        <a:rPr sz="1800">
                           <a:solidFill>
-                            <a:srgbClr val="191919"/>
+                            <a:srgbClr val="000000"/>
                           </a:solidFill>
-                          <a:latin typeface="Arial"/>
                         </a:rPr>
                         <a:t>Connect to CDM in Databricks, DBeaver, or your site's client</a:t>
                       </a:r>
                     </a:p>
                   </a:txBody>
-                  <a:tcPr>
-                    <a:solidFill>
-                      <a:srgbClr val="FFFFFF"/>
-                    </a:solidFill>
-                  </a:tcPr>
+                  <a:tcPr marL="73152" marR="73152" marT="27432" marB="27432"/>
                 </a:tc>
                 <a:tc>
                   <a:txBody>
-                    <a:bodyPr lIns="63500" tIns="25400"/>
+                    <a:bodyPr wrap="square"/>
                     <a:lstStyle/>
                     <a:p>
                       <a:r>
-                        <a:rPr sz="1300">
+                        <a:rPr sz="1800">
                           <a:solidFill>
-                            <a:srgbClr val="191919"/>
+                            <a:srgbClr val="000000"/>
                           </a:solidFill>
-                          <a:latin typeface="Arial"/>
                         </a:rPr>
                         <a:t>☐ Done  ☐ Blocked</a:t>
                       </a:r>
                     </a:p>
                   </a:txBody>
-                  <a:tcPr>
-                    <a:solidFill>
-                      <a:srgbClr val="FFFFFF"/>
-                    </a:solidFill>
-                  </a:tcPr>
+                  <a:tcPr marL="73152" marR="73152" marT="27432" marB="27432"/>
                 </a:tc>
               </a:tr>
-              <a:tr h="566928">
+              <a:tr h="400050">
                 <a:tc>
                   <a:txBody>
-                    <a:bodyPr lIns="63500" tIns="25400"/>
+                    <a:bodyPr wrap="square"/>
                     <a:lstStyle/>
                     <a:p>
                       <a:r>
-                        <a:rPr sz="1300">
+                        <a:rPr sz="1800">
                           <a:solidFill>
-                            <a:srgbClr val="191919"/>
+                            <a:srgbClr val="000000"/>
                           </a:solidFill>
-                          <a:latin typeface="Arial"/>
                         </a:rPr>
                         <a:t>Git / GitHub</a:t>
                       </a:r>
                     </a:p>
                   </a:txBody>
-                  <a:tcPr>
-                    <a:solidFill>
-                      <a:srgbClr val="F6F6F6"/>
-                    </a:solidFill>
-                  </a:tcPr>
+                  <a:tcPr marL="73152" marR="73152" marT="27432" marB="27432"/>
                 </a:tc>
                 <a:tc>
                   <a:txBody>
-                    <a:bodyPr lIns="63500" tIns="25400"/>
+                    <a:bodyPr wrap="square"/>
                     <a:lstStyle/>
                     <a:p>
                       <a:r>
-                        <a:rPr sz="1300">
+                        <a:rPr sz="1800">
                           <a:solidFill>
-                            <a:srgbClr val="191919"/>
+                            <a:srgbClr val="000000"/>
                           </a:solidFill>
-                          <a:latin typeface="Arial"/>
                         </a:rPr>
                         <a:t>Clone the program repo: git clone [repo-url]</a:t>
                       </a:r>
                     </a:p>
                   </a:txBody>
-                  <a:tcPr>
-                    <a:solidFill>
-                      <a:srgbClr val="F6F6F6"/>
-                    </a:solidFill>
-                  </a:tcPr>
+                  <a:tcPr marL="73152" marR="73152" marT="27432" marB="27432"/>
                 </a:tc>
                 <a:tc>
                   <a:txBody>
-                    <a:bodyPr lIns="63500" tIns="25400"/>
+                    <a:bodyPr wrap="square"/>
                     <a:lstStyle/>
                     <a:p>
                       <a:r>
-                        <a:rPr sz="1300">
+                        <a:rPr sz="1800">
                           <a:solidFill>
-                            <a:srgbClr val="191919"/>
+                            <a:srgbClr val="000000"/>
                           </a:solidFill>
-                          <a:latin typeface="Arial"/>
                         </a:rPr>
                         <a:t>☐ Done  ☐ Blocked</a:t>
                       </a:r>
                     </a:p>
                   </a:txBody>
-                  <a:tcPr>
-                    <a:solidFill>
-                      <a:srgbClr val="F6F6F6"/>
-                    </a:solidFill>
-                  </a:tcPr>
+                  <a:tcPr marL="73152" marR="73152" marT="27432" marB="27432"/>
                 </a:tc>
               </a:tr>
-              <a:tr h="566928">
+              <a:tr h="685800">
                 <a:tc>
                   <a:txBody>
-                    <a:bodyPr lIns="63500" tIns="25400"/>
+                    <a:bodyPr wrap="square"/>
                     <a:lstStyle/>
                     <a:p>
                       <a:r>
-                        <a:rPr sz="1300">
+                        <a:rPr sz="1800">
                           <a:solidFill>
-                            <a:srgbClr val="191919"/>
+                            <a:srgbClr val="000000"/>
                           </a:solidFill>
-                          <a:latin typeface="Arial"/>
                         </a:rPr>
                         <a:t>R / HADES (Day 6)</a:t>
                       </a:r>
                     </a:p>
                   </a:txBody>
-                  <a:tcPr>
-                    <a:solidFill>
-                      <a:srgbClr val="FFFFFF"/>
-                    </a:solidFill>
-                  </a:tcPr>
+                  <a:tcPr marL="73152" marR="73152" marT="27432" marB="27432"/>
                 </a:tc>
                 <a:tc>
                   <a:txBody>
-                    <a:bodyPr lIns="63500" tIns="25400"/>
+                    <a:bodyPr wrap="square"/>
                     <a:lstStyle/>
                     <a:p>
                       <a:r>
-                        <a:rPr sz="1300">
+                        <a:rPr sz="1800">
                           <a:solidFill>
-                            <a:srgbClr val="191919"/>
+                            <a:srgbClr val="000000"/>
                           </a:solidFill>
-                          <a:latin typeface="Arial"/>
                         </a:rPr>
                         <a:t>Install DatabaseConnector and run library(DatabaseConnector)</a:t>
                       </a:r>
                     </a:p>
                   </a:txBody>
-                  <a:tcPr>
-                    <a:solidFill>
-                      <a:srgbClr val="FFFFFF"/>
-                    </a:solidFill>
-                  </a:tcPr>
+                  <a:tcPr marL="73152" marR="73152" marT="27432" marB="27432"/>
                 </a:tc>
                 <a:tc>
                   <a:txBody>
-                    <a:bodyPr lIns="63500" tIns="25400"/>
+                    <a:bodyPr wrap="square"/>
                     <a:lstStyle/>
                     <a:p>
                       <a:r>
-                        <a:rPr sz="1300">
+                        <a:rPr sz="1800">
                           <a:solidFill>
-                            <a:srgbClr val="191919"/>
+                            <a:srgbClr val="000000"/>
                           </a:solidFill>
-                          <a:latin typeface="Arial"/>
                         </a:rPr>
                         <a:t>☐ Done  ☐ N/A</a:t>
                       </a:r>
                     </a:p>
                   </a:txBody>
-                  <a:tcPr>
-                    <a:solidFill>
-                      <a:srgbClr val="FFFFFF"/>
-                    </a:solidFill>
-                  </a:tcPr>
+                  <a:tcPr marL="73152" marR="73152" marT="27432" marB="27432"/>
                 </a:tc>
               </a:tr>
             </a:tbl>
@@ -4067,120 +3615,20 @@
       <p:grpSpPr/>
       <p:sp>
         <p:nvSpPr>
-          <p:cNvPr id="2" name="Rectangle 1"/>
-          <p:cNvSpPr/>
-          <p:nvPr/>
-        </p:nvSpPr>
-        <p:spPr>
-          <a:xfrm>
-            <a:off x="0" y="0"/>
-            <a:ext cx="12188952" cy="960120"/>
-          </a:xfrm>
-          <a:prstGeom prst="rect">
-            <a:avLst/>
-          </a:prstGeom>
-          <a:solidFill>
-            <a:srgbClr val="20425A"/>
-          </a:solidFill>
-          <a:ln>
-            <a:noFill/>
-          </a:ln>
-        </p:spPr>
-        <p:style>
-          <a:lnRef idx="1">
-            <a:schemeClr val="accent1"/>
-          </a:lnRef>
-          <a:fillRef idx="3">
-            <a:schemeClr val="accent1"/>
-          </a:fillRef>
-          <a:effectRef idx="2">
-            <a:schemeClr val="accent1"/>
-          </a:effectRef>
-          <a:fontRef idx="minor">
-            <a:schemeClr val="lt1"/>
-          </a:fontRef>
-        </p:style>
-        <p:txBody>
-          <a:bodyPr rtlCol="0" anchor="ctr"/>
-          <a:lstStyle/>
-          <a:p>
-            <a:pPr algn="ctr"/>
-          </a:p>
-        </p:txBody>
-      </p:sp>
-      <p:sp>
-        <p:nvSpPr>
-          <p:cNvPr id="3" name="Rectangle 2"/>
-          <p:cNvSpPr/>
-          <p:nvPr/>
-        </p:nvSpPr>
-        <p:spPr>
-          <a:xfrm>
-            <a:off x="0" y="905256"/>
-            <a:ext cx="12188952" cy="54864"/>
-          </a:xfrm>
-          <a:prstGeom prst="rect">
-            <a:avLst/>
-          </a:prstGeom>
-          <a:solidFill>
-            <a:srgbClr val="904199"/>
-          </a:solidFill>
-          <a:ln>
-            <a:noFill/>
-          </a:ln>
-        </p:spPr>
-        <p:style>
-          <a:lnRef idx="1">
-            <a:schemeClr val="accent1"/>
-          </a:lnRef>
-          <a:fillRef idx="3">
-            <a:schemeClr val="accent1"/>
-          </a:fillRef>
-          <a:effectRef idx="2">
-            <a:schemeClr val="accent1"/>
-          </a:effectRef>
-          <a:fontRef idx="minor">
-            <a:schemeClr val="lt1"/>
-          </a:fontRef>
-        </p:style>
-        <p:txBody>
-          <a:bodyPr rtlCol="0" anchor="ctr"/>
-          <a:lstStyle/>
-          <a:p>
-            <a:pPr algn="ctr"/>
-          </a:p>
-        </p:txBody>
-      </p:sp>
-      <p:sp>
-        <p:nvSpPr>
-          <p:cNvPr id="4" name="TextBox 3"/>
-          <p:cNvSpPr txBox="1"/>
-          <p:nvPr/>
-        </p:nvSpPr>
-        <p:spPr>
-          <a:xfrm>
-            <a:off x="475488" y="137160"/>
-            <a:ext cx="11713464" cy="777240"/>
-          </a:xfrm>
-          <a:prstGeom prst="rect">
-            <a:avLst/>
-          </a:prstGeom>
-          <a:noFill/>
-        </p:spPr>
-        <p:txBody>
-          <a:bodyPr wrap="square">
-            <a:spAutoFit/>
-          </a:bodyPr>
-          <a:lstStyle/>
-          <a:p>
-            <a:pPr algn="l"/>
-            <a:r>
-              <a:rPr sz="2800" b="1" i="0">
-                <a:solidFill>
-                  <a:srgbClr val="FFFFFF"/>
-                </a:solidFill>
-                <a:latin typeface="Gotham Narrow"/>
-              </a:rPr>
+          <p:cNvPr id="2" name="Title 1"/>
+          <p:cNvSpPr>
+            <a:spLocks noGrp="1"/>
+          </p:cNvSpPr>
+          <p:nvPr>
+            <p:ph type="title"/>
+          </p:nvPr>
+        </p:nvSpPr>
+        <p:spPr/>
+        <p:txBody>
+          <a:bodyPr/>
+          <a:lstStyle/>
+          <a:p>
+            <a:r>
               <a:t>Quick Verification Steps (Do Before Day 1)</a:t>
             </a:r>
           </a:p>
@@ -4188,150 +3636,74 @@
       </p:sp>
       <p:sp>
         <p:nvSpPr>
-          <p:cNvPr id="5" name="TextBox 4"/>
-          <p:cNvSpPr txBox="1"/>
-          <p:nvPr/>
-        </p:nvSpPr>
-        <p:spPr>
-          <a:xfrm>
-            <a:off x="475488" y="1161288"/>
-            <a:ext cx="11237976" cy="5495544"/>
-          </a:xfrm>
-          <a:prstGeom prst="rect">
-            <a:avLst/>
-          </a:prstGeom>
-          <a:noFill/>
-        </p:spPr>
-        <p:txBody>
-          <a:bodyPr wrap="square">
-            <a:spAutoFit/>
-          </a:bodyPr>
-          <a:lstStyle/>
-          <a:p>
-            <a:pPr>
-              <a:spcBef>
-                <a:spcPts val="600"/>
-              </a:spcBef>
+          <p:cNvPr id="3" name="Content Placeholder 2"/>
+          <p:cNvSpPr>
+            <a:spLocks noGrp="1"/>
+          </p:cNvSpPr>
+          <p:nvPr>
+            <p:ph idx="1"/>
+          </p:nvPr>
+        </p:nvSpPr>
+        <p:spPr/>
+        <p:txBody>
+          <a:bodyPr/>
+          <a:lstStyle/>
+          <a:p>
+            <a:pPr marL="0" indent="0">
+              <a:buNone/>
             </a:pPr>
             <a:r>
-              <a:rPr sz="1800">
-                <a:solidFill>
-                  <a:srgbClr val="191919"/>
-                </a:solidFill>
-                <a:latin typeface="Arial"/>
-              </a:rPr>
+              <a:rPr sz="2200"/>
               <a:t>1.  Log in to ATLAS → create a test concept set → export JSON → delete it</a:t>
             </a:r>
           </a:p>
           <a:p>
-            <a:pPr>
-              <a:spcBef>
-                <a:spcPts val="600"/>
-              </a:spcBef>
+            <a:pPr marL="0" indent="0">
+              <a:buNone/>
             </a:pPr>
             <a:r>
-              <a:rPr sz="1800">
-                <a:solidFill>
-                  <a:srgbClr val="191919"/>
-                </a:solidFill>
-                <a:latin typeface="Arial"/>
-              </a:rPr>
+              <a:rPr sz="2200"/>
               <a:t>2.  Run in your SQL client: SELECT * FROM [cdm_schema].person LIMIT 5;</a:t>
             </a:r>
           </a:p>
           <a:p>
-            <a:pPr>
-              <a:spcBef>
-                <a:spcPts val="600"/>
-              </a:spcBef>
+            <a:pPr marL="0" indent="0">
+              <a:buNone/>
             </a:pPr>
             <a:r>
-              <a:rPr sz="1800">
-                <a:solidFill>
-                  <a:srgbClr val="191919"/>
-                </a:solidFill>
-                <a:latin typeface="Arial"/>
-              </a:rPr>
+              <a:rPr sz="2200"/>
               <a:t>3.  Open athena.ohdsi.org → search 'Metformin' → confirm results appear</a:t>
             </a:r>
           </a:p>
           <a:p>
-            <a:pPr>
-              <a:spcBef>
-                <a:spcPts val="600"/>
-              </a:spcBef>
+            <a:pPr marL="0" indent="0">
+              <a:buNone/>
             </a:pPr>
             <a:r>
-              <a:rPr sz="1800">
-                <a:solidFill>
-                  <a:srgbClr val="191919"/>
-                </a:solidFill>
-                <a:latin typeface="Arial"/>
-              </a:rPr>
+              <a:rPr sz="2200"/>
               <a:t>4.  In a terminal: git --version → should return a version number</a:t>
             </a:r>
           </a:p>
           <a:p>
-            <a:pPr>
-              <a:spcBef>
-                <a:spcPts val="600"/>
-              </a:spcBef>
+            <a:pPr marL="0" indent="0">
+              <a:buNone/>
             </a:pPr>
             <a:r>
-              <a:rPr sz="1800">
-                <a:solidFill>
-                  <a:srgbClr val="191919"/>
-                </a:solidFill>
-                <a:latin typeface="Arial"/>
-              </a:rPr>
+              <a:rPr sz="2200"/>
               <a:t>5.  Clone the program repository (URL from your trainer)</a:t>
             </a:r>
           </a:p>
           <a:p>
-            <a:pPr>
-              <a:spcBef>
-                <a:spcPts val="600"/>
-              </a:spcBef>
-            </a:pPr>
-            <a:r>
-              <a:rPr sz="1800">
-                <a:solidFill>
-                  <a:srgbClr val="191919"/>
-                </a:solidFill>
-                <a:latin typeface="Arial"/>
-              </a:rPr>
-              <a:t/>
-            </a:r>
-          </a:p>
-          <a:p>
-            <a:pPr>
-              <a:spcBef>
-                <a:spcPts val="600"/>
-              </a:spcBef>
-            </a:pPr>
-            <a:r>
-              <a:rPr sz="1800">
-                <a:solidFill>
-                  <a:srgbClr val="191919"/>
-                </a:solidFill>
-                <a:latin typeface="Arial"/>
-              </a:rPr>
+            <a:pPr/>
+            <a:r>
+              <a:rPr sz="2200"/>
               <a:t>If all five work → you are ready for Day 1</a:t>
             </a:r>
           </a:p>
           <a:p>
-            <a:pPr>
-              <a:spcBef>
-                <a:spcPts val="600"/>
-              </a:spcBef>
-            </a:pPr>
-            <a:r>
-              <a:rPr sz="1800">
-                <a:solidFill>
-                  <a:srgbClr val="191919"/>
-                </a:solidFill>
-                <a:latin typeface="Arial"/>
-              </a:rPr>
+            <a:pPr/>
+            <a:r>
+              <a:rPr sz="2200"/>
               <a:t>If anything is blocked → contact your site support contact NOW</a:t>
             </a:r>
           </a:p>
@@ -4357,120 +3729,20 @@
       <p:grpSpPr/>
       <p:sp>
         <p:nvSpPr>
-          <p:cNvPr id="2" name="Rectangle 1"/>
-          <p:cNvSpPr/>
-          <p:nvPr/>
-        </p:nvSpPr>
-        <p:spPr>
-          <a:xfrm>
-            <a:off x="0" y="0"/>
-            <a:ext cx="12188952" cy="960120"/>
-          </a:xfrm>
-          <a:prstGeom prst="rect">
-            <a:avLst/>
-          </a:prstGeom>
-          <a:solidFill>
-            <a:srgbClr val="20425A"/>
-          </a:solidFill>
-          <a:ln>
-            <a:noFill/>
-          </a:ln>
-        </p:spPr>
-        <p:style>
-          <a:lnRef idx="1">
-            <a:schemeClr val="accent1"/>
-          </a:lnRef>
-          <a:fillRef idx="3">
-            <a:schemeClr val="accent1"/>
-          </a:fillRef>
-          <a:effectRef idx="2">
-            <a:schemeClr val="accent1"/>
-          </a:effectRef>
-          <a:fontRef idx="minor">
-            <a:schemeClr val="lt1"/>
-          </a:fontRef>
-        </p:style>
-        <p:txBody>
-          <a:bodyPr rtlCol="0" anchor="ctr"/>
-          <a:lstStyle/>
-          <a:p>
-            <a:pPr algn="ctr"/>
-          </a:p>
-        </p:txBody>
-      </p:sp>
-      <p:sp>
-        <p:nvSpPr>
-          <p:cNvPr id="3" name="Rectangle 2"/>
-          <p:cNvSpPr/>
-          <p:nvPr/>
-        </p:nvSpPr>
-        <p:spPr>
-          <a:xfrm>
-            <a:off x="0" y="905256"/>
-            <a:ext cx="12188952" cy="54864"/>
-          </a:xfrm>
-          <a:prstGeom prst="rect">
-            <a:avLst/>
-          </a:prstGeom>
-          <a:solidFill>
-            <a:srgbClr val="904199"/>
-          </a:solidFill>
-          <a:ln>
-            <a:noFill/>
-          </a:ln>
-        </p:spPr>
-        <p:style>
-          <a:lnRef idx="1">
-            <a:schemeClr val="accent1"/>
-          </a:lnRef>
-          <a:fillRef idx="3">
-            <a:schemeClr val="accent1"/>
-          </a:fillRef>
-          <a:effectRef idx="2">
-            <a:schemeClr val="accent1"/>
-          </a:effectRef>
-          <a:fontRef idx="minor">
-            <a:schemeClr val="lt1"/>
-          </a:fontRef>
-        </p:style>
-        <p:txBody>
-          <a:bodyPr rtlCol="0" anchor="ctr"/>
-          <a:lstStyle/>
-          <a:p>
-            <a:pPr algn="ctr"/>
-          </a:p>
-        </p:txBody>
-      </p:sp>
-      <p:sp>
-        <p:nvSpPr>
-          <p:cNvPr id="4" name="TextBox 3"/>
-          <p:cNvSpPr txBox="1"/>
-          <p:nvPr/>
-        </p:nvSpPr>
-        <p:spPr>
-          <a:xfrm>
-            <a:off x="475488" y="137160"/>
-            <a:ext cx="11713464" cy="777240"/>
-          </a:xfrm>
-          <a:prstGeom prst="rect">
-            <a:avLst/>
-          </a:prstGeom>
-          <a:noFill/>
-        </p:spPr>
-        <p:txBody>
-          <a:bodyPr wrap="square">
-            <a:spAutoFit/>
-          </a:bodyPr>
-          <a:lstStyle/>
-          <a:p>
-            <a:pPr algn="l"/>
-            <a:r>
-              <a:rPr sz="2800" b="1" i="0">
-                <a:solidFill>
-                  <a:srgbClr val="FFFFFF"/>
-                </a:solidFill>
-                <a:latin typeface="Gotham Narrow"/>
-              </a:rPr>
+          <p:cNvPr id="2" name="Title 1"/>
+          <p:cNvSpPr>
+            <a:spLocks noGrp="1"/>
+          </p:cNvSpPr>
+          <p:nvPr>
+            <p:ph type="title"/>
+          </p:nvPr>
+        </p:nvSpPr>
+        <p:spPr/>
+        <p:txBody>
+          <a:bodyPr/>
+          <a:lstStyle/>
+          <a:p>
+            <a:r>
               <a:t>Your Site's Configuration (Fill In)</a:t>
             </a:r>
           </a:p>
@@ -4478,150 +3750,71 @@
       </p:sp>
       <p:sp>
         <p:nvSpPr>
-          <p:cNvPr id="5" name="TextBox 4"/>
-          <p:cNvSpPr txBox="1"/>
-          <p:nvPr/>
-        </p:nvSpPr>
-        <p:spPr>
-          <a:xfrm>
-            <a:off x="475488" y="1161288"/>
-            <a:ext cx="11237976" cy="5495544"/>
-          </a:xfrm>
-          <a:prstGeom prst="rect">
-            <a:avLst/>
-          </a:prstGeom>
-          <a:noFill/>
-        </p:spPr>
-        <p:txBody>
-          <a:bodyPr wrap="square">
-            <a:spAutoFit/>
-          </a:bodyPr>
-          <a:lstStyle/>
-          <a:p>
-            <a:pPr>
-              <a:spcBef>
-                <a:spcPts val="600"/>
-              </a:spcBef>
-            </a:pPr>
-            <a:r>
-              <a:rPr sz="1700">
-                <a:solidFill>
-                  <a:srgbClr val="191919"/>
-                </a:solidFill>
-                <a:latin typeface="Arial"/>
-              </a:rPr>
+          <p:cNvPr id="3" name="Content Placeholder 2"/>
+          <p:cNvSpPr>
+            <a:spLocks noGrp="1"/>
+          </p:cNvSpPr>
+          <p:nvPr>
+            <p:ph idx="1"/>
+          </p:nvPr>
+        </p:nvSpPr>
+        <p:spPr/>
+        <p:txBody>
+          <a:bodyPr/>
+          <a:lstStyle/>
+          <a:p>
+            <a:pPr/>
+            <a:r>
+              <a:rPr sz="2400"/>
               <a:t>ATLAS URL:   _______________________________________________</a:t>
             </a:r>
           </a:p>
           <a:p>
-            <a:pPr>
-              <a:spcBef>
-                <a:spcPts val="600"/>
-              </a:spcBef>
-            </a:pPr>
-            <a:r>
-              <a:rPr sz="1700">
-                <a:solidFill>
-                  <a:srgbClr val="191919"/>
-                </a:solidFill>
-                <a:latin typeface="Arial"/>
-              </a:rPr>
+            <a:pPr/>
+            <a:r>
+              <a:rPr sz="2400"/>
               <a:t>Warehouse / CDM Host:   ____________________________________</a:t>
             </a:r>
           </a:p>
           <a:p>
-            <a:pPr>
-              <a:spcBef>
-                <a:spcPts val="600"/>
-              </a:spcBef>
-            </a:pPr>
-            <a:r>
-              <a:rPr sz="1700">
-                <a:solidFill>
-                  <a:srgbClr val="191919"/>
-                </a:solidFill>
-                <a:latin typeface="Arial"/>
-              </a:rPr>
+            <a:pPr/>
+            <a:r>
+              <a:rPr sz="2400"/>
               <a:t>CDM Schema:   ______________________________________________</a:t>
             </a:r>
           </a:p>
           <a:p>
-            <a:pPr>
-              <a:spcBef>
-                <a:spcPts val="600"/>
-              </a:spcBef>
-            </a:pPr>
-            <a:r>
-              <a:rPr sz="1700">
-                <a:solidFill>
-                  <a:srgbClr val="191919"/>
-                </a:solidFill>
-                <a:latin typeface="Arial"/>
-              </a:rPr>
+            <a:pPr/>
+            <a:r>
+              <a:rPr sz="2400"/>
               <a:t>Results Schema:   __________________________________________</a:t>
             </a:r>
           </a:p>
           <a:p>
-            <a:pPr>
-              <a:spcBef>
-                <a:spcPts val="600"/>
-              </a:spcBef>
-            </a:pPr>
-            <a:r>
-              <a:rPr sz="1700">
-                <a:solidFill>
-                  <a:srgbClr val="191919"/>
-                </a:solidFill>
-                <a:latin typeface="Arial"/>
-              </a:rPr>
+            <a:pPr/>
+            <a:r>
+              <a:rPr sz="2400"/>
               <a:t>SQL Client (Databricks / DBeaver / other):   ________________</a:t>
             </a:r>
           </a:p>
           <a:p>
-            <a:pPr>
-              <a:spcBef>
-                <a:spcPts val="600"/>
-              </a:spcBef>
-            </a:pPr>
-            <a:r>
-              <a:rPr sz="1700">
-                <a:solidFill>
-                  <a:srgbClr val="191919"/>
-                </a:solidFill>
-                <a:latin typeface="Arial"/>
-              </a:rPr>
-              <a:t>Extraction Tool (SEARCH / Atlas SQL / pipeline):   __________</a:t>
-            </a:r>
-          </a:p>
-          <a:p>
-            <a:pPr>
-              <a:spcBef>
-                <a:spcPts val="600"/>
-              </a:spcBef>
-            </a:pPr>
-            <a:r>
-              <a:rPr sz="1700">
-                <a:solidFill>
-                  <a:srgbClr val="191919"/>
-                </a:solidFill>
-                <a:latin typeface="Arial"/>
-              </a:rPr>
+            <a:pPr/>
+            <a:r>
+              <a:rPr sz="2400"/>
+              <a:t>Extraction Method (ATLAS SQL / pipeline):   __________</a:t>
+            </a:r>
+          </a:p>
+          <a:p>
+            <a:pPr/>
+            <a:r>
+              <a:rPr sz="2400"/>
               <a:t>Support Contact (data access):   ____________________________</a:t>
             </a:r>
           </a:p>
           <a:p>
-            <a:pPr>
-              <a:spcBef>
-                <a:spcPts val="600"/>
-              </a:spcBef>
-            </a:pPr>
-            <a:r>
-              <a:rPr sz="1700">
-                <a:solidFill>
-                  <a:srgbClr val="191919"/>
-                </a:solidFill>
-                <a:latin typeface="Arial"/>
-              </a:rPr>
+            <a:pPr/>
+            <a:r>
+              <a:rPr sz="2400"/>
               <a:t>Support Contact (ATLAS admin):   ____________________________</a:t>
             </a:r>
           </a:p>
@@ -4647,163 +3840,20 @@
       <p:grpSpPr/>
       <p:sp>
         <p:nvSpPr>
-          <p:cNvPr id="2" name="Rectangle 1"/>
-          <p:cNvSpPr/>
-          <p:nvPr/>
-        </p:nvSpPr>
-        <p:spPr>
-          <a:xfrm>
-            <a:off x="0" y="0"/>
-            <a:ext cx="12188952" cy="6858000"/>
-          </a:xfrm>
-          <a:prstGeom prst="rect">
-            <a:avLst/>
-          </a:prstGeom>
-          <a:solidFill>
-            <a:srgbClr val="20425A"/>
-          </a:solidFill>
-          <a:ln>
-            <a:noFill/>
-          </a:ln>
-        </p:spPr>
-        <p:style>
-          <a:lnRef idx="1">
-            <a:schemeClr val="accent1"/>
-          </a:lnRef>
-          <a:fillRef idx="3">
-            <a:schemeClr val="accent1"/>
-          </a:fillRef>
-          <a:effectRef idx="2">
-            <a:schemeClr val="accent1"/>
-          </a:effectRef>
-          <a:fontRef idx="minor">
-            <a:schemeClr val="lt1"/>
-          </a:fontRef>
-        </p:style>
-        <p:txBody>
-          <a:bodyPr rtlCol="0" anchor="ctr"/>
-          <a:lstStyle/>
-          <a:p>
-            <a:pPr algn="ctr"/>
-          </a:p>
-        </p:txBody>
-      </p:sp>
-      <p:sp>
-        <p:nvSpPr>
-          <p:cNvPr id="3" name="Rectangle 2"/>
-          <p:cNvSpPr/>
-          <p:nvPr/>
-        </p:nvSpPr>
-        <p:spPr>
-          <a:xfrm>
-            <a:off x="0" y="0"/>
-            <a:ext cx="12188952" cy="64008"/>
-          </a:xfrm>
-          <a:prstGeom prst="rect">
-            <a:avLst/>
-          </a:prstGeom>
-          <a:solidFill>
-            <a:srgbClr val="904199"/>
-          </a:solidFill>
-          <a:ln>
-            <a:noFill/>
-          </a:ln>
-        </p:spPr>
-        <p:style>
-          <a:lnRef idx="1">
-            <a:schemeClr val="accent1"/>
-          </a:lnRef>
-          <a:fillRef idx="3">
-            <a:schemeClr val="accent1"/>
-          </a:fillRef>
-          <a:effectRef idx="2">
-            <a:schemeClr val="accent1"/>
-          </a:effectRef>
-          <a:fontRef idx="minor">
-            <a:schemeClr val="lt1"/>
-          </a:fontRef>
-        </p:style>
-        <p:txBody>
-          <a:bodyPr rtlCol="0" anchor="ctr"/>
-          <a:lstStyle/>
-          <a:p>
-            <a:pPr algn="ctr"/>
-          </a:p>
-        </p:txBody>
-      </p:sp>
-      <p:sp>
-        <p:nvSpPr>
-          <p:cNvPr id="4" name="Rectangle 3"/>
-          <p:cNvSpPr/>
-          <p:nvPr/>
-        </p:nvSpPr>
-        <p:spPr>
-          <a:xfrm>
-            <a:off x="0" y="6793992"/>
-            <a:ext cx="12188952" cy="64008"/>
-          </a:xfrm>
-          <a:prstGeom prst="rect">
-            <a:avLst/>
-          </a:prstGeom>
-          <a:solidFill>
-            <a:srgbClr val="904199"/>
-          </a:solidFill>
-          <a:ln>
-            <a:noFill/>
-          </a:ln>
-        </p:spPr>
-        <p:style>
-          <a:lnRef idx="1">
-            <a:schemeClr val="accent1"/>
-          </a:lnRef>
-          <a:fillRef idx="3">
-            <a:schemeClr val="accent1"/>
-          </a:fillRef>
-          <a:effectRef idx="2">
-            <a:schemeClr val="accent1"/>
-          </a:effectRef>
-          <a:fontRef idx="minor">
-            <a:schemeClr val="lt1"/>
-          </a:fontRef>
-        </p:style>
-        <p:txBody>
-          <a:bodyPr rtlCol="0" anchor="ctr"/>
-          <a:lstStyle/>
-          <a:p>
-            <a:pPr algn="ctr"/>
-          </a:p>
-        </p:txBody>
-      </p:sp>
-      <p:sp>
-        <p:nvSpPr>
-          <p:cNvPr id="5" name="TextBox 4"/>
-          <p:cNvSpPr txBox="1"/>
-          <p:nvPr/>
-        </p:nvSpPr>
-        <p:spPr>
-          <a:xfrm>
-            <a:off x="475488" y="1828800"/>
-            <a:ext cx="11237976" cy="1188720"/>
-          </a:xfrm>
-          <a:prstGeom prst="rect">
-            <a:avLst/>
-          </a:prstGeom>
-          <a:noFill/>
-        </p:spPr>
-        <p:txBody>
-          <a:bodyPr wrap="square">
-            <a:spAutoFit/>
-          </a:bodyPr>
-          <a:lstStyle/>
-          <a:p>
-            <a:pPr algn="l"/>
-            <a:r>
-              <a:rPr sz="4400" b="1" i="0">
-                <a:solidFill>
-                  <a:srgbClr val="FFFFFF"/>
-                </a:solidFill>
-                <a:latin typeface="Gotham Narrow"/>
-              </a:rPr>
+          <p:cNvPr id="2" name="Title 1"/>
+          <p:cNvSpPr>
+            <a:spLocks noGrp="1"/>
+          </p:cNvSpPr>
+          <p:nvPr>
+            <p:ph type="title"/>
+          </p:nvPr>
+        </p:nvSpPr>
+        <p:spPr/>
+        <p:txBody>
+          <a:bodyPr/>
+          <a:lstStyle/>
+          <a:p>
+            <a:r>
               <a:t>Thank You.  Questions?</a:t>
             </a:r>
           </a:p>
@@ -4811,104 +3861,39 @@
       </p:sp>
       <p:sp>
         <p:nvSpPr>
-          <p:cNvPr id="6" name="TextBox 5"/>
-          <p:cNvSpPr txBox="1"/>
-          <p:nvPr/>
-        </p:nvSpPr>
-        <p:spPr>
-          <a:xfrm>
-            <a:off x="475488" y="3383280"/>
-            <a:ext cx="11237976" cy="640080"/>
-          </a:xfrm>
-          <a:prstGeom prst="rect">
-            <a:avLst/>
-          </a:prstGeom>
-          <a:noFill/>
-        </p:spPr>
-        <p:txBody>
-          <a:bodyPr wrap="square">
-            <a:spAutoFit/>
-          </a:bodyPr>
-          <a:lstStyle/>
-          <a:p>
-            <a:pPr algn="l"/>
-            <a:r>
-              <a:rPr sz="2400" b="0" i="0">
-                <a:solidFill>
-                  <a:srgbClr val="FFFFFF"/>
-                </a:solidFill>
-                <a:latin typeface="Arial"/>
-              </a:rPr>
+          <p:cNvPr id="3" name="Text Placeholder 2"/>
+          <p:cNvSpPr>
+            <a:spLocks noGrp="1"/>
+          </p:cNvSpPr>
+          <p:nvPr>
+            <p:ph type="body" idx="1"/>
+          </p:nvPr>
+        </p:nvSpPr>
+        <p:spPr/>
+        <p:txBody>
+          <a:bodyPr/>
+          <a:lstStyle/>
+          <a:p>
+            <a:pPr marL="0" indent="0">
+              <a:buNone/>
+            </a:pPr>
+            <a:r>
               <a:t>Danielle Boyce</a:t>
             </a:r>
           </a:p>
-        </p:txBody>
-      </p:sp>
-      <p:sp>
-        <p:nvSpPr>
-          <p:cNvPr id="7" name="TextBox 6"/>
-          <p:cNvSpPr txBox="1"/>
-          <p:nvPr/>
-        </p:nvSpPr>
-        <p:spPr>
-          <a:xfrm>
-            <a:off x="475488" y="3977639"/>
-            <a:ext cx="11237976" cy="640080"/>
-          </a:xfrm>
-          <a:prstGeom prst="rect">
-            <a:avLst/>
-          </a:prstGeom>
-          <a:noFill/>
-        </p:spPr>
-        <p:txBody>
-          <a:bodyPr wrap="square">
-            <a:spAutoFit/>
-          </a:bodyPr>
-          <a:lstStyle/>
-          <a:p>
-            <a:pPr algn="l"/>
-            <a:r>
-              <a:rPr sz="2200" b="0" i="0">
-                <a:solidFill>
-                  <a:srgbClr val="D9C4E6"/>
-                </a:solidFill>
-                <a:latin typeface="Arial"/>
-              </a:rPr>
+          <a:p>
+            <a:pPr marL="0" indent="0">
+              <a:buNone/>
+            </a:pPr>
+            <a:r>
               <a:t>dboyce@als.net</a:t>
             </a:r>
           </a:p>
-        </p:txBody>
-      </p:sp>
-      <p:sp>
-        <p:nvSpPr>
-          <p:cNvPr id="8" name="TextBox 7"/>
-          <p:cNvSpPr txBox="1"/>
-          <p:nvPr/>
-        </p:nvSpPr>
-        <p:spPr>
-          <a:xfrm>
-            <a:off x="475488" y="6309360"/>
-            <a:ext cx="8229600" cy="365760"/>
-          </a:xfrm>
-          <a:prstGeom prst="rect">
-            <a:avLst/>
-          </a:prstGeom>
-          <a:noFill/>
-        </p:spPr>
-        <p:txBody>
-          <a:bodyPr wrap="square">
-            <a:spAutoFit/>
-          </a:bodyPr>
-          <a:lstStyle/>
-          <a:p>
-            <a:pPr algn="l"/>
-            <a:r>
-              <a:rPr sz="1300" b="0" i="0">
-                <a:solidFill>
-                  <a:srgbClr val="AEC4D2"/>
-                </a:solidFill>
-                <a:latin typeface="Arial"/>
-              </a:rPr>
+          <a:p>
+            <a:pPr marL="0" indent="0">
+              <a:buNone/>
+            </a:pPr>
+            <a:r>
               <a:t>ALS TDI · OHDSI/OMOP Train-the-Trainer</a:t>
             </a:r>
           </a:p>
@@ -4933,34 +3918,34 @@
         <a:sysClr val="window" lastClr="FFFFFF"/>
       </a:lt1>
       <a:dk2>
-        <a:srgbClr val="1F497D"/>
+        <a:srgbClr val="262626"/>
       </a:dk2>
       <a:lt2>
-        <a:srgbClr val="EEECE1"/>
+        <a:srgbClr val="F2F2F2"/>
       </a:lt2>
       <a:accent1>
-        <a:srgbClr val="4F81BD"/>
+        <a:srgbClr val="404040"/>
       </a:accent1>
       <a:accent2>
-        <a:srgbClr val="C0504D"/>
+        <a:srgbClr val="7F7F7F"/>
       </a:accent2>
       <a:accent3>
-        <a:srgbClr val="9BBB59"/>
+        <a:srgbClr val="A6A6A6"/>
       </a:accent3>
       <a:accent4>
-        <a:srgbClr val="8064A2"/>
+        <a:srgbClr val="595959"/>
       </a:accent4>
       <a:accent5>
-        <a:srgbClr val="4BACC6"/>
+        <a:srgbClr val="BFBFBF"/>
       </a:accent5>
       <a:accent6>
-        <a:srgbClr val="F79646"/>
+        <a:srgbClr val="262626"/>
       </a:accent6>
       <a:hlink>
-        <a:srgbClr val="0000FF"/>
+        <a:srgbClr val="000000"/>
       </a:hlink>
       <a:folHlink>
-        <a:srgbClr val="800080"/>
+        <a:srgbClr val="404040"/>
       </a:folHlink>
     </a:clrScheme>
     <a:fontScheme name="Office">

</xml_diff>